<commit_message>
sligth changes to admin form,edited presentation and added regex to pass change
</commit_message>
<xml_diff>
--- a/lbpMonkey.pptx
+++ b/lbpMonkey.pptx
@@ -5,13 +5,14 @@
     <p:sldMasterId id="2147483671" r:id="rId1"/>
   </p:sldMasterIdLst>
   <p:notesMasterIdLst>
-    <p:notesMasterId r:id="rId6"/>
+    <p:notesMasterId r:id="rId7"/>
   </p:notesMasterIdLst>
   <p:sldIdLst>
     <p:sldId id="256" r:id="rId2"/>
     <p:sldId id="268" r:id="rId3"/>
     <p:sldId id="257" r:id="rId4"/>
     <p:sldId id="298" r:id="rId5"/>
+    <p:sldId id="299" r:id="rId6"/>
   </p:sldIdLst>
   <p:sldSz cx="9144000" cy="5143500" type="screen16x9"/>
   <p:notesSz cx="6858000" cy="9144000"/>
@@ -244,6 +245,11 @@
       </a:defRPr>
     </a:lvl9pPr>
   </p:defaultTextStyle>
+  <p:extLst>
+    <p:ext uri="{EFAFB233-063F-42B5-8137-9DF3F51BA10A}">
+      <p15:sldGuideLst xmlns:p15="http://schemas.microsoft.com/office/powerpoint/2012/main"/>
+    </p:ext>
+  </p:extLst>
 </p:presentation>
 </file>
 
@@ -1100,6 +1106,115 @@
     <p:extLst>
       <p:ext uri="{BB962C8B-B14F-4D97-AF65-F5344CB8AC3E}">
         <p14:creationId xmlns:p14="http://schemas.microsoft.com/office/powerpoint/2010/main" val="552586156"/>
+      </p:ext>
+    </p:extLst>
+  </p:cSld>
+  <p:clrMapOvr>
+    <a:masterClrMapping/>
+  </p:clrMapOvr>
+</p:notes>
+</file>
+
+<file path=ppt/notesSlides/notesSlide5.xml><?xml version="1.0" encoding="utf-8"?>
+<p:notes xmlns:a="http://schemas.openxmlformats.org/drawingml/2006/main" xmlns:r="http://schemas.openxmlformats.org/officeDocument/2006/relationships" xmlns:p="http://schemas.openxmlformats.org/presentationml/2006/main" showMasterSp="0" showMasterPhAnim="0">
+  <p:cSld>
+    <p:spTree>
+      <p:nvGrpSpPr>
+        <p:cNvPr id="1" name="Shape 272"/>
+        <p:cNvGrpSpPr/>
+        <p:nvPr/>
+      </p:nvGrpSpPr>
+      <p:grpSpPr>
+        <a:xfrm>
+          <a:off x="0" y="0"/>
+          <a:ext cx="0" cy="0"/>
+          <a:chOff x="0" y="0"/>
+          <a:chExt cx="0" cy="0"/>
+        </a:xfrm>
+      </p:grpSpPr>
+      <p:sp>
+        <p:nvSpPr>
+          <p:cNvPr id="273" name="Google Shape;273;g2d294afe249_0_272:notes"/>
+          <p:cNvSpPr>
+            <a:spLocks noGrp="1" noRot="1" noChangeAspect="1"/>
+          </p:cNvSpPr>
+          <p:nvPr>
+            <p:ph type="sldImg" idx="2"/>
+          </p:nvPr>
+        </p:nvSpPr>
+        <p:spPr>
+          <a:xfrm>
+            <a:off x="381000" y="685800"/>
+            <a:ext cx="6096000" cy="3429000"/>
+          </a:xfrm>
+          <a:custGeom>
+            <a:avLst/>
+            <a:gdLst/>
+            <a:ahLst/>
+            <a:cxnLst/>
+            <a:rect l="l" t="t" r="r" b="b"/>
+            <a:pathLst>
+              <a:path w="120000" h="120000" extrusionOk="0">
+                <a:moveTo>
+                  <a:pt x="0" y="0"/>
+                </a:moveTo>
+                <a:lnTo>
+                  <a:pt x="120000" y="0"/>
+                </a:lnTo>
+                <a:lnTo>
+                  <a:pt x="120000" y="120000"/>
+                </a:lnTo>
+                <a:lnTo>
+                  <a:pt x="0" y="120000"/>
+                </a:lnTo>
+                <a:close/>
+              </a:path>
+            </a:pathLst>
+          </a:custGeom>
+        </p:spPr>
+      </p:sp>
+      <p:sp>
+        <p:nvSpPr>
+          <p:cNvPr id="274" name="Google Shape;274;g2d294afe249_0_272:notes"/>
+          <p:cNvSpPr txBox="1">
+            <a:spLocks noGrp="1"/>
+          </p:cNvSpPr>
+          <p:nvPr>
+            <p:ph type="body" idx="1"/>
+          </p:nvPr>
+        </p:nvSpPr>
+        <p:spPr>
+          <a:xfrm>
+            <a:off x="685800" y="4343400"/>
+            <a:ext cx="5486400" cy="4114800"/>
+          </a:xfrm>
+          <a:prstGeom prst="rect">
+            <a:avLst/>
+          </a:prstGeom>
+        </p:spPr>
+        <p:txBody>
+          <a:bodyPr spcFirstLastPara="1" wrap="square" lIns="91425" tIns="91425" rIns="91425" bIns="91425" anchor="t" anchorCtr="0">
+            <a:noAutofit/>
+          </a:bodyPr>
+          <a:lstStyle/>
+          <a:p>
+            <a:pPr marL="0" lvl="0" indent="0" algn="l" rtl="0">
+              <a:spcBef>
+                <a:spcPts val="0"/>
+              </a:spcBef>
+              <a:spcAft>
+                <a:spcPts val="0"/>
+              </a:spcAft>
+              <a:buNone/>
+            </a:pPr>
+            <a:endParaRPr/>
+          </a:p>
+        </p:txBody>
+      </p:sp>
+    </p:spTree>
+    <p:extLst>
+      <p:ext uri="{BB962C8B-B14F-4D97-AF65-F5344CB8AC3E}">
+        <p14:creationId xmlns:p14="http://schemas.microsoft.com/office/powerpoint/2010/main" val="998626151"/>
       </p:ext>
     </p:extLst>
   </p:cSld>
@@ -18705,7 +18820,7 @@
           <p:nvPr>
             <p:extLst>
               <p:ext uri="{D42A27DB-BD31-4B8C-83A1-F6EECF244321}">
-                <p14:modId xmlns:p14="http://schemas.microsoft.com/office/powerpoint/2010/main" val="2453940778"/>
+                <p14:modId xmlns:p14="http://schemas.microsoft.com/office/powerpoint/2010/main" val="268995931"/>
               </p:ext>
             </p:extLst>
           </p:nvPr>
@@ -19752,7 +19867,7 @@
                           <a:cs typeface="Hind"/>
                           <a:sym typeface="Hind"/>
                         </a:rPr>
-                        <a:t>Italiano,Spagnolo</a:t>
+                        <a:t>Italiano,Spagnolo,Francese,Tedesco</a:t>
                       </a:r>
                       <a:r>
                         <a:rPr lang="it-IT" sz="1100" dirty="0">
@@ -25541,7 +25656,7 @@
                 <a:cs typeface="Hind"/>
                 <a:sym typeface="Hind"/>
               </a:rPr>
-              <a:t>Dettagli carta con possibilità di aggiunta carte di massa</a:t>
+              <a:t>Dettagli carta con possibilità di aggiunta di carte alla collezione in massa</a:t>
             </a:r>
             <a:endParaRPr sz="1100" dirty="0">
               <a:solidFill>
@@ -29506,6 +29621,346 @@
 </p:sld>
 </file>
 
+<file path=ppt/slides/slide5.xml><?xml version="1.0" encoding="utf-8"?>
+<p:sld xmlns:a="http://schemas.openxmlformats.org/drawingml/2006/main" xmlns:r="http://schemas.openxmlformats.org/officeDocument/2006/relationships" xmlns:p="http://schemas.openxmlformats.org/presentationml/2006/main">
+  <p:cSld>
+    <p:spTree>
+      <p:nvGrpSpPr>
+        <p:cNvPr id="1" name="Shape 275"/>
+        <p:cNvGrpSpPr/>
+        <p:nvPr/>
+      </p:nvGrpSpPr>
+      <p:grpSpPr>
+        <a:xfrm>
+          <a:off x="0" y="0"/>
+          <a:ext cx="0" cy="0"/>
+          <a:chOff x="0" y="0"/>
+          <a:chExt cx="0" cy="0"/>
+        </a:xfrm>
+      </p:grpSpPr>
+      <p:pic>
+        <p:nvPicPr>
+          <p:cNvPr id="2" name="Picture 4">
+            <a:extLst>
+              <a:ext uri="{FF2B5EF4-FFF2-40B4-BE49-F238E27FC236}">
+                <a16:creationId xmlns:a16="http://schemas.microsoft.com/office/drawing/2014/main" id="{96D5E329-B837-6DDD-18F1-E80B8C3025A3}"/>
+              </a:ext>
+            </a:extLst>
+          </p:cNvPr>
+          <p:cNvPicPr>
+            <a:picLocks noChangeAspect="1" noChangeArrowheads="1"/>
+          </p:cNvPicPr>
+          <p:nvPr/>
+        </p:nvPicPr>
+        <p:blipFill>
+          <a:blip r:embed="rId3">
+            <a:extLst>
+              <a:ext uri="{28A0092B-C50C-407E-A947-70E740481C1C}">
+                <a14:useLocalDpi xmlns:a14="http://schemas.microsoft.com/office/drawing/2010/main" val="0"/>
+              </a:ext>
+            </a:extLst>
+          </a:blip>
+          <a:srcRect/>
+          <a:stretch>
+            <a:fillRect/>
+          </a:stretch>
+        </p:blipFill>
+        <p:spPr bwMode="auto">
+          <a:xfrm>
+            <a:off x="2990290" y="403412"/>
+            <a:ext cx="3163420" cy="3163420"/>
+          </a:xfrm>
+          <a:prstGeom prst="rect">
+            <a:avLst/>
+          </a:prstGeom>
+          <a:noFill/>
+          <a:extLst>
+            <a:ext uri="{909E8E84-426E-40DD-AFC4-6F175D3DCCD1}">
+              <a14:hiddenFill xmlns:a14="http://schemas.microsoft.com/office/drawing/2010/main">
+                <a:solidFill>
+                  <a:srgbClr val="FFFFFF"/>
+                </a:solidFill>
+              </a14:hiddenFill>
+            </a:ext>
+          </a:extLst>
+        </p:spPr>
+      </p:pic>
+      <p:pic>
+        <p:nvPicPr>
+          <p:cNvPr id="3" name="Picture 2">
+            <a:extLst>
+              <a:ext uri="{FF2B5EF4-FFF2-40B4-BE49-F238E27FC236}">
+                <a16:creationId xmlns:a16="http://schemas.microsoft.com/office/drawing/2014/main" id="{1F7BBAF3-9A78-E220-24A8-5AFCD3815647}"/>
+              </a:ext>
+            </a:extLst>
+          </p:cNvPr>
+          <p:cNvPicPr>
+            <a:picLocks noChangeAspect="1" noChangeArrowheads="1"/>
+          </p:cNvPicPr>
+          <p:nvPr/>
+        </p:nvPicPr>
+        <p:blipFill>
+          <a:blip r:embed="rId4">
+            <a:extLst>
+              <a:ext uri="{28A0092B-C50C-407E-A947-70E740481C1C}">
+                <a14:useLocalDpi xmlns:a14="http://schemas.microsoft.com/office/drawing/2010/main" val="0"/>
+              </a:ext>
+            </a:extLst>
+          </a:blip>
+          <a:srcRect/>
+          <a:stretch>
+            <a:fillRect/>
+          </a:stretch>
+        </p:blipFill>
+        <p:spPr bwMode="auto">
+          <a:xfrm>
+            <a:off x="1950547" y="2168785"/>
+            <a:ext cx="5242906" cy="1720328"/>
+          </a:xfrm>
+          <a:prstGeom prst="rect">
+            <a:avLst/>
+          </a:prstGeom>
+          <a:noFill/>
+          <a:extLst>
+            <a:ext uri="{909E8E84-426E-40DD-AFC4-6F175D3DCCD1}">
+              <a14:hiddenFill xmlns:a14="http://schemas.microsoft.com/office/drawing/2010/main">
+                <a:solidFill>
+                  <a:srgbClr val="FFFFFF"/>
+                </a:solidFill>
+              </a14:hiddenFill>
+            </a:ext>
+          </a:extLst>
+        </p:spPr>
+      </p:pic>
+    </p:spTree>
+    <p:extLst>
+      <p:ext uri="{BB962C8B-B14F-4D97-AF65-F5344CB8AC3E}">
+        <p14:creationId xmlns:p14="http://schemas.microsoft.com/office/powerpoint/2010/main" val="3929589779"/>
+      </p:ext>
+    </p:extLst>
+  </p:cSld>
+  <p:clrMapOvr>
+    <a:masterClrMapping/>
+  </p:clrMapOvr>
+  <p:timing>
+    <p:tnLst>
+      <p:par>
+        <p:cTn id="1" dur="indefinite" restart="never" nodeType="tmRoot">
+          <p:childTnLst>
+            <p:seq concurrent="1" nextAc="seek">
+              <p:cTn id="2" dur="indefinite" nodeType="mainSeq">
+                <p:childTnLst>
+                  <p:par>
+                    <p:cTn id="3" fill="hold">
+                      <p:stCondLst>
+                        <p:cond delay="indefinite"/>
+                      </p:stCondLst>
+                      <p:childTnLst>
+                        <p:par>
+                          <p:cTn id="4" fill="hold">
+                            <p:stCondLst>
+                              <p:cond delay="0"/>
+                            </p:stCondLst>
+                            <p:childTnLst>
+                              <p:par>
+                                <p:cTn id="5" presetID="32" presetClass="emph" presetSubtype="0" fill="hold" nodeType="clickEffect">
+                                  <p:stCondLst>
+                                    <p:cond delay="0"/>
+                                  </p:stCondLst>
+                                  <p:childTnLst>
+                                    <p:animRot by="120000">
+                                      <p:cBhvr>
+                                        <p:cTn id="6" dur="100" fill="hold">
+                                          <p:stCondLst>
+                                            <p:cond delay="0"/>
+                                          </p:stCondLst>
+                                        </p:cTn>
+                                        <p:tgtEl>
+                                          <p:spTgt spid="3"/>
+                                        </p:tgtEl>
+                                        <p:attrNameLst>
+                                          <p:attrName>r</p:attrName>
+                                        </p:attrNameLst>
+                                      </p:cBhvr>
+                                    </p:animRot>
+                                    <p:animRot by="-240000">
+                                      <p:cBhvr>
+                                        <p:cTn id="7" dur="200" fill="hold">
+                                          <p:stCondLst>
+                                            <p:cond delay="200"/>
+                                          </p:stCondLst>
+                                        </p:cTn>
+                                        <p:tgtEl>
+                                          <p:spTgt spid="3"/>
+                                        </p:tgtEl>
+                                        <p:attrNameLst>
+                                          <p:attrName>r</p:attrName>
+                                        </p:attrNameLst>
+                                      </p:cBhvr>
+                                    </p:animRot>
+                                    <p:animRot by="240000">
+                                      <p:cBhvr>
+                                        <p:cTn id="8" dur="200" fill="hold">
+                                          <p:stCondLst>
+                                            <p:cond delay="400"/>
+                                          </p:stCondLst>
+                                        </p:cTn>
+                                        <p:tgtEl>
+                                          <p:spTgt spid="3"/>
+                                        </p:tgtEl>
+                                        <p:attrNameLst>
+                                          <p:attrName>r</p:attrName>
+                                        </p:attrNameLst>
+                                      </p:cBhvr>
+                                    </p:animRot>
+                                    <p:animRot by="-240000">
+                                      <p:cBhvr>
+                                        <p:cTn id="9" dur="200" fill="hold">
+                                          <p:stCondLst>
+                                            <p:cond delay="600"/>
+                                          </p:stCondLst>
+                                        </p:cTn>
+                                        <p:tgtEl>
+                                          <p:spTgt spid="3"/>
+                                        </p:tgtEl>
+                                        <p:attrNameLst>
+                                          <p:attrName>r</p:attrName>
+                                        </p:attrNameLst>
+                                      </p:cBhvr>
+                                    </p:animRot>
+                                    <p:animRot by="120000">
+                                      <p:cBhvr>
+                                        <p:cTn id="10" dur="200" fill="hold">
+                                          <p:stCondLst>
+                                            <p:cond delay="800"/>
+                                          </p:stCondLst>
+                                        </p:cTn>
+                                        <p:tgtEl>
+                                          <p:spTgt spid="3"/>
+                                        </p:tgtEl>
+                                        <p:attrNameLst>
+                                          <p:attrName>r</p:attrName>
+                                        </p:attrNameLst>
+                                      </p:cBhvr>
+                                    </p:animRot>
+                                  </p:childTnLst>
+                                </p:cTn>
+                              </p:par>
+                              <p:par>
+                                <p:cTn id="11" presetID="32" presetClass="emph" presetSubtype="0" fill="hold" nodeType="withEffect">
+                                  <p:stCondLst>
+                                    <p:cond delay="0"/>
+                                  </p:stCondLst>
+                                  <p:childTnLst>
+                                    <p:animRot by="120000">
+                                      <p:cBhvr>
+                                        <p:cTn id="12" dur="100" fill="hold">
+                                          <p:stCondLst>
+                                            <p:cond delay="0"/>
+                                          </p:stCondLst>
+                                        </p:cTn>
+                                        <p:tgtEl>
+                                          <p:spTgt spid="2"/>
+                                        </p:tgtEl>
+                                        <p:attrNameLst>
+                                          <p:attrName>r</p:attrName>
+                                        </p:attrNameLst>
+                                      </p:cBhvr>
+                                    </p:animRot>
+                                    <p:animRot by="-240000">
+                                      <p:cBhvr>
+                                        <p:cTn id="13" dur="200" fill="hold">
+                                          <p:stCondLst>
+                                            <p:cond delay="200"/>
+                                          </p:stCondLst>
+                                        </p:cTn>
+                                        <p:tgtEl>
+                                          <p:spTgt spid="2"/>
+                                        </p:tgtEl>
+                                        <p:attrNameLst>
+                                          <p:attrName>r</p:attrName>
+                                        </p:attrNameLst>
+                                      </p:cBhvr>
+                                    </p:animRot>
+                                    <p:animRot by="240000">
+                                      <p:cBhvr>
+                                        <p:cTn id="14" dur="200" fill="hold">
+                                          <p:stCondLst>
+                                            <p:cond delay="400"/>
+                                          </p:stCondLst>
+                                        </p:cTn>
+                                        <p:tgtEl>
+                                          <p:spTgt spid="2"/>
+                                        </p:tgtEl>
+                                        <p:attrNameLst>
+                                          <p:attrName>r</p:attrName>
+                                        </p:attrNameLst>
+                                      </p:cBhvr>
+                                    </p:animRot>
+                                    <p:animRot by="-240000">
+                                      <p:cBhvr>
+                                        <p:cTn id="15" dur="200" fill="hold">
+                                          <p:stCondLst>
+                                            <p:cond delay="600"/>
+                                          </p:stCondLst>
+                                        </p:cTn>
+                                        <p:tgtEl>
+                                          <p:spTgt spid="2"/>
+                                        </p:tgtEl>
+                                        <p:attrNameLst>
+                                          <p:attrName>r</p:attrName>
+                                        </p:attrNameLst>
+                                      </p:cBhvr>
+                                    </p:animRot>
+                                    <p:animRot by="120000">
+                                      <p:cBhvr>
+                                        <p:cTn id="16" dur="200" fill="hold">
+                                          <p:stCondLst>
+                                            <p:cond delay="800"/>
+                                          </p:stCondLst>
+                                        </p:cTn>
+                                        <p:tgtEl>
+                                          <p:spTgt spid="2"/>
+                                        </p:tgtEl>
+                                        <p:attrNameLst>
+                                          <p:attrName>r</p:attrName>
+                                        </p:attrNameLst>
+                                      </p:cBhvr>
+                                    </p:animRot>
+                                  </p:childTnLst>
+                                </p:cTn>
+                              </p:par>
+                            </p:childTnLst>
+                          </p:cTn>
+                        </p:par>
+                      </p:childTnLst>
+                    </p:cTn>
+                  </p:par>
+                </p:childTnLst>
+              </p:cTn>
+              <p:prevCondLst>
+                <p:cond evt="onPrev" delay="0">
+                  <p:tgtEl>
+                    <p:sldTgt/>
+                  </p:tgtEl>
+                </p:cond>
+              </p:prevCondLst>
+              <p:nextCondLst>
+                <p:cond evt="onNext" delay="0">
+                  <p:tgtEl>
+                    <p:sldTgt/>
+                  </p:tgtEl>
+                </p:cond>
+              </p:nextCondLst>
+            </p:seq>
+          </p:childTnLst>
+        </p:cTn>
+      </p:par>
+    </p:tnLst>
+  </p:timing>
+</p:sld>
+</file>
+
 <file path=ppt/theme/theme1.xml><?xml version="1.0" encoding="utf-8"?>
 <a:theme xmlns:a="http://schemas.openxmlformats.org/drawingml/2006/main" name="College Lessons with Cycle Diagrams by Slidesgo">
   <a:themeElements>

</xml_diff>

<commit_message>
sligth changes to admin form,edited presentation and added regex to pass change (#269)
</commit_message>
<xml_diff>
--- a/lbpMonkey.pptx
+++ b/lbpMonkey.pptx
@@ -5,13 +5,14 @@
     <p:sldMasterId id="2147483671" r:id="rId1"/>
   </p:sldMasterIdLst>
   <p:notesMasterIdLst>
-    <p:notesMasterId r:id="rId6"/>
+    <p:notesMasterId r:id="rId7"/>
   </p:notesMasterIdLst>
   <p:sldIdLst>
     <p:sldId id="256" r:id="rId2"/>
     <p:sldId id="268" r:id="rId3"/>
     <p:sldId id="257" r:id="rId4"/>
     <p:sldId id="298" r:id="rId5"/>
+    <p:sldId id="299" r:id="rId6"/>
   </p:sldIdLst>
   <p:sldSz cx="9144000" cy="5143500" type="screen16x9"/>
   <p:notesSz cx="6858000" cy="9144000"/>
@@ -244,6 +245,11 @@
       </a:defRPr>
     </a:lvl9pPr>
   </p:defaultTextStyle>
+  <p:extLst>
+    <p:ext uri="{EFAFB233-063F-42B5-8137-9DF3F51BA10A}">
+      <p15:sldGuideLst xmlns:p15="http://schemas.microsoft.com/office/powerpoint/2012/main"/>
+    </p:ext>
+  </p:extLst>
 </p:presentation>
 </file>
 
@@ -1100,6 +1106,115 @@
     <p:extLst>
       <p:ext uri="{BB962C8B-B14F-4D97-AF65-F5344CB8AC3E}">
         <p14:creationId xmlns:p14="http://schemas.microsoft.com/office/powerpoint/2010/main" val="552586156"/>
+      </p:ext>
+    </p:extLst>
+  </p:cSld>
+  <p:clrMapOvr>
+    <a:masterClrMapping/>
+  </p:clrMapOvr>
+</p:notes>
+</file>
+
+<file path=ppt/notesSlides/notesSlide5.xml><?xml version="1.0" encoding="utf-8"?>
+<p:notes xmlns:a="http://schemas.openxmlformats.org/drawingml/2006/main" xmlns:r="http://schemas.openxmlformats.org/officeDocument/2006/relationships" xmlns:p="http://schemas.openxmlformats.org/presentationml/2006/main" showMasterSp="0" showMasterPhAnim="0">
+  <p:cSld>
+    <p:spTree>
+      <p:nvGrpSpPr>
+        <p:cNvPr id="1" name="Shape 272"/>
+        <p:cNvGrpSpPr/>
+        <p:nvPr/>
+      </p:nvGrpSpPr>
+      <p:grpSpPr>
+        <a:xfrm>
+          <a:off x="0" y="0"/>
+          <a:ext cx="0" cy="0"/>
+          <a:chOff x="0" y="0"/>
+          <a:chExt cx="0" cy="0"/>
+        </a:xfrm>
+      </p:grpSpPr>
+      <p:sp>
+        <p:nvSpPr>
+          <p:cNvPr id="273" name="Google Shape;273;g2d294afe249_0_272:notes"/>
+          <p:cNvSpPr>
+            <a:spLocks noGrp="1" noRot="1" noChangeAspect="1"/>
+          </p:cNvSpPr>
+          <p:nvPr>
+            <p:ph type="sldImg" idx="2"/>
+          </p:nvPr>
+        </p:nvSpPr>
+        <p:spPr>
+          <a:xfrm>
+            <a:off x="381000" y="685800"/>
+            <a:ext cx="6096000" cy="3429000"/>
+          </a:xfrm>
+          <a:custGeom>
+            <a:avLst/>
+            <a:gdLst/>
+            <a:ahLst/>
+            <a:cxnLst/>
+            <a:rect l="l" t="t" r="r" b="b"/>
+            <a:pathLst>
+              <a:path w="120000" h="120000" extrusionOk="0">
+                <a:moveTo>
+                  <a:pt x="0" y="0"/>
+                </a:moveTo>
+                <a:lnTo>
+                  <a:pt x="120000" y="0"/>
+                </a:lnTo>
+                <a:lnTo>
+                  <a:pt x="120000" y="120000"/>
+                </a:lnTo>
+                <a:lnTo>
+                  <a:pt x="0" y="120000"/>
+                </a:lnTo>
+                <a:close/>
+              </a:path>
+            </a:pathLst>
+          </a:custGeom>
+        </p:spPr>
+      </p:sp>
+      <p:sp>
+        <p:nvSpPr>
+          <p:cNvPr id="274" name="Google Shape;274;g2d294afe249_0_272:notes"/>
+          <p:cNvSpPr txBox="1">
+            <a:spLocks noGrp="1"/>
+          </p:cNvSpPr>
+          <p:nvPr>
+            <p:ph type="body" idx="1"/>
+          </p:nvPr>
+        </p:nvSpPr>
+        <p:spPr>
+          <a:xfrm>
+            <a:off x="685800" y="4343400"/>
+            <a:ext cx="5486400" cy="4114800"/>
+          </a:xfrm>
+          <a:prstGeom prst="rect">
+            <a:avLst/>
+          </a:prstGeom>
+        </p:spPr>
+        <p:txBody>
+          <a:bodyPr spcFirstLastPara="1" wrap="square" lIns="91425" tIns="91425" rIns="91425" bIns="91425" anchor="t" anchorCtr="0">
+            <a:noAutofit/>
+          </a:bodyPr>
+          <a:lstStyle/>
+          <a:p>
+            <a:pPr marL="0" lvl="0" indent="0" algn="l" rtl="0">
+              <a:spcBef>
+                <a:spcPts val="0"/>
+              </a:spcBef>
+              <a:spcAft>
+                <a:spcPts val="0"/>
+              </a:spcAft>
+              <a:buNone/>
+            </a:pPr>
+            <a:endParaRPr/>
+          </a:p>
+        </p:txBody>
+      </p:sp>
+    </p:spTree>
+    <p:extLst>
+      <p:ext uri="{BB962C8B-B14F-4D97-AF65-F5344CB8AC3E}">
+        <p14:creationId xmlns:p14="http://schemas.microsoft.com/office/powerpoint/2010/main" val="998626151"/>
       </p:ext>
     </p:extLst>
   </p:cSld>
@@ -18705,7 +18820,7 @@
           <p:nvPr>
             <p:extLst>
               <p:ext uri="{D42A27DB-BD31-4B8C-83A1-F6EECF244321}">
-                <p14:modId xmlns:p14="http://schemas.microsoft.com/office/powerpoint/2010/main" val="2453940778"/>
+                <p14:modId xmlns:p14="http://schemas.microsoft.com/office/powerpoint/2010/main" val="268995931"/>
               </p:ext>
             </p:extLst>
           </p:nvPr>
@@ -19752,7 +19867,7 @@
                           <a:cs typeface="Hind"/>
                           <a:sym typeface="Hind"/>
                         </a:rPr>
-                        <a:t>Italiano,Spagnolo</a:t>
+                        <a:t>Italiano,Spagnolo,Francese,Tedesco</a:t>
                       </a:r>
                       <a:r>
                         <a:rPr lang="it-IT" sz="1100" dirty="0">
@@ -25541,7 +25656,7 @@
                 <a:cs typeface="Hind"/>
                 <a:sym typeface="Hind"/>
               </a:rPr>
-              <a:t>Dettagli carta con possibilità di aggiunta carte di massa</a:t>
+              <a:t>Dettagli carta con possibilità di aggiunta di carte alla collezione in massa</a:t>
             </a:r>
             <a:endParaRPr sz="1100" dirty="0">
               <a:solidFill>
@@ -29506,6 +29621,346 @@
 </p:sld>
 </file>
 
+<file path=ppt/slides/slide5.xml><?xml version="1.0" encoding="utf-8"?>
+<p:sld xmlns:a="http://schemas.openxmlformats.org/drawingml/2006/main" xmlns:r="http://schemas.openxmlformats.org/officeDocument/2006/relationships" xmlns:p="http://schemas.openxmlformats.org/presentationml/2006/main">
+  <p:cSld>
+    <p:spTree>
+      <p:nvGrpSpPr>
+        <p:cNvPr id="1" name="Shape 275"/>
+        <p:cNvGrpSpPr/>
+        <p:nvPr/>
+      </p:nvGrpSpPr>
+      <p:grpSpPr>
+        <a:xfrm>
+          <a:off x="0" y="0"/>
+          <a:ext cx="0" cy="0"/>
+          <a:chOff x="0" y="0"/>
+          <a:chExt cx="0" cy="0"/>
+        </a:xfrm>
+      </p:grpSpPr>
+      <p:pic>
+        <p:nvPicPr>
+          <p:cNvPr id="2" name="Picture 4">
+            <a:extLst>
+              <a:ext uri="{FF2B5EF4-FFF2-40B4-BE49-F238E27FC236}">
+                <a16:creationId xmlns:a16="http://schemas.microsoft.com/office/drawing/2014/main" id="{96D5E329-B837-6DDD-18F1-E80B8C3025A3}"/>
+              </a:ext>
+            </a:extLst>
+          </p:cNvPr>
+          <p:cNvPicPr>
+            <a:picLocks noChangeAspect="1" noChangeArrowheads="1"/>
+          </p:cNvPicPr>
+          <p:nvPr/>
+        </p:nvPicPr>
+        <p:blipFill>
+          <a:blip r:embed="rId3">
+            <a:extLst>
+              <a:ext uri="{28A0092B-C50C-407E-A947-70E740481C1C}">
+                <a14:useLocalDpi xmlns:a14="http://schemas.microsoft.com/office/drawing/2010/main" val="0"/>
+              </a:ext>
+            </a:extLst>
+          </a:blip>
+          <a:srcRect/>
+          <a:stretch>
+            <a:fillRect/>
+          </a:stretch>
+        </p:blipFill>
+        <p:spPr bwMode="auto">
+          <a:xfrm>
+            <a:off x="2990290" y="403412"/>
+            <a:ext cx="3163420" cy="3163420"/>
+          </a:xfrm>
+          <a:prstGeom prst="rect">
+            <a:avLst/>
+          </a:prstGeom>
+          <a:noFill/>
+          <a:extLst>
+            <a:ext uri="{909E8E84-426E-40DD-AFC4-6F175D3DCCD1}">
+              <a14:hiddenFill xmlns:a14="http://schemas.microsoft.com/office/drawing/2010/main">
+                <a:solidFill>
+                  <a:srgbClr val="FFFFFF"/>
+                </a:solidFill>
+              </a14:hiddenFill>
+            </a:ext>
+          </a:extLst>
+        </p:spPr>
+      </p:pic>
+      <p:pic>
+        <p:nvPicPr>
+          <p:cNvPr id="3" name="Picture 2">
+            <a:extLst>
+              <a:ext uri="{FF2B5EF4-FFF2-40B4-BE49-F238E27FC236}">
+                <a16:creationId xmlns:a16="http://schemas.microsoft.com/office/drawing/2014/main" id="{1F7BBAF3-9A78-E220-24A8-5AFCD3815647}"/>
+              </a:ext>
+            </a:extLst>
+          </p:cNvPr>
+          <p:cNvPicPr>
+            <a:picLocks noChangeAspect="1" noChangeArrowheads="1"/>
+          </p:cNvPicPr>
+          <p:nvPr/>
+        </p:nvPicPr>
+        <p:blipFill>
+          <a:blip r:embed="rId4">
+            <a:extLst>
+              <a:ext uri="{28A0092B-C50C-407E-A947-70E740481C1C}">
+                <a14:useLocalDpi xmlns:a14="http://schemas.microsoft.com/office/drawing/2010/main" val="0"/>
+              </a:ext>
+            </a:extLst>
+          </a:blip>
+          <a:srcRect/>
+          <a:stretch>
+            <a:fillRect/>
+          </a:stretch>
+        </p:blipFill>
+        <p:spPr bwMode="auto">
+          <a:xfrm>
+            <a:off x="1950547" y="2168785"/>
+            <a:ext cx="5242906" cy="1720328"/>
+          </a:xfrm>
+          <a:prstGeom prst="rect">
+            <a:avLst/>
+          </a:prstGeom>
+          <a:noFill/>
+          <a:extLst>
+            <a:ext uri="{909E8E84-426E-40DD-AFC4-6F175D3DCCD1}">
+              <a14:hiddenFill xmlns:a14="http://schemas.microsoft.com/office/drawing/2010/main">
+                <a:solidFill>
+                  <a:srgbClr val="FFFFFF"/>
+                </a:solidFill>
+              </a14:hiddenFill>
+            </a:ext>
+          </a:extLst>
+        </p:spPr>
+      </p:pic>
+    </p:spTree>
+    <p:extLst>
+      <p:ext uri="{BB962C8B-B14F-4D97-AF65-F5344CB8AC3E}">
+        <p14:creationId xmlns:p14="http://schemas.microsoft.com/office/powerpoint/2010/main" val="3929589779"/>
+      </p:ext>
+    </p:extLst>
+  </p:cSld>
+  <p:clrMapOvr>
+    <a:masterClrMapping/>
+  </p:clrMapOvr>
+  <p:timing>
+    <p:tnLst>
+      <p:par>
+        <p:cTn id="1" dur="indefinite" restart="never" nodeType="tmRoot">
+          <p:childTnLst>
+            <p:seq concurrent="1" nextAc="seek">
+              <p:cTn id="2" dur="indefinite" nodeType="mainSeq">
+                <p:childTnLst>
+                  <p:par>
+                    <p:cTn id="3" fill="hold">
+                      <p:stCondLst>
+                        <p:cond delay="indefinite"/>
+                      </p:stCondLst>
+                      <p:childTnLst>
+                        <p:par>
+                          <p:cTn id="4" fill="hold">
+                            <p:stCondLst>
+                              <p:cond delay="0"/>
+                            </p:stCondLst>
+                            <p:childTnLst>
+                              <p:par>
+                                <p:cTn id="5" presetID="32" presetClass="emph" presetSubtype="0" fill="hold" nodeType="clickEffect">
+                                  <p:stCondLst>
+                                    <p:cond delay="0"/>
+                                  </p:stCondLst>
+                                  <p:childTnLst>
+                                    <p:animRot by="120000">
+                                      <p:cBhvr>
+                                        <p:cTn id="6" dur="100" fill="hold">
+                                          <p:stCondLst>
+                                            <p:cond delay="0"/>
+                                          </p:stCondLst>
+                                        </p:cTn>
+                                        <p:tgtEl>
+                                          <p:spTgt spid="3"/>
+                                        </p:tgtEl>
+                                        <p:attrNameLst>
+                                          <p:attrName>r</p:attrName>
+                                        </p:attrNameLst>
+                                      </p:cBhvr>
+                                    </p:animRot>
+                                    <p:animRot by="-240000">
+                                      <p:cBhvr>
+                                        <p:cTn id="7" dur="200" fill="hold">
+                                          <p:stCondLst>
+                                            <p:cond delay="200"/>
+                                          </p:stCondLst>
+                                        </p:cTn>
+                                        <p:tgtEl>
+                                          <p:spTgt spid="3"/>
+                                        </p:tgtEl>
+                                        <p:attrNameLst>
+                                          <p:attrName>r</p:attrName>
+                                        </p:attrNameLst>
+                                      </p:cBhvr>
+                                    </p:animRot>
+                                    <p:animRot by="240000">
+                                      <p:cBhvr>
+                                        <p:cTn id="8" dur="200" fill="hold">
+                                          <p:stCondLst>
+                                            <p:cond delay="400"/>
+                                          </p:stCondLst>
+                                        </p:cTn>
+                                        <p:tgtEl>
+                                          <p:spTgt spid="3"/>
+                                        </p:tgtEl>
+                                        <p:attrNameLst>
+                                          <p:attrName>r</p:attrName>
+                                        </p:attrNameLst>
+                                      </p:cBhvr>
+                                    </p:animRot>
+                                    <p:animRot by="-240000">
+                                      <p:cBhvr>
+                                        <p:cTn id="9" dur="200" fill="hold">
+                                          <p:stCondLst>
+                                            <p:cond delay="600"/>
+                                          </p:stCondLst>
+                                        </p:cTn>
+                                        <p:tgtEl>
+                                          <p:spTgt spid="3"/>
+                                        </p:tgtEl>
+                                        <p:attrNameLst>
+                                          <p:attrName>r</p:attrName>
+                                        </p:attrNameLst>
+                                      </p:cBhvr>
+                                    </p:animRot>
+                                    <p:animRot by="120000">
+                                      <p:cBhvr>
+                                        <p:cTn id="10" dur="200" fill="hold">
+                                          <p:stCondLst>
+                                            <p:cond delay="800"/>
+                                          </p:stCondLst>
+                                        </p:cTn>
+                                        <p:tgtEl>
+                                          <p:spTgt spid="3"/>
+                                        </p:tgtEl>
+                                        <p:attrNameLst>
+                                          <p:attrName>r</p:attrName>
+                                        </p:attrNameLst>
+                                      </p:cBhvr>
+                                    </p:animRot>
+                                  </p:childTnLst>
+                                </p:cTn>
+                              </p:par>
+                              <p:par>
+                                <p:cTn id="11" presetID="32" presetClass="emph" presetSubtype="0" fill="hold" nodeType="withEffect">
+                                  <p:stCondLst>
+                                    <p:cond delay="0"/>
+                                  </p:stCondLst>
+                                  <p:childTnLst>
+                                    <p:animRot by="120000">
+                                      <p:cBhvr>
+                                        <p:cTn id="12" dur="100" fill="hold">
+                                          <p:stCondLst>
+                                            <p:cond delay="0"/>
+                                          </p:stCondLst>
+                                        </p:cTn>
+                                        <p:tgtEl>
+                                          <p:spTgt spid="2"/>
+                                        </p:tgtEl>
+                                        <p:attrNameLst>
+                                          <p:attrName>r</p:attrName>
+                                        </p:attrNameLst>
+                                      </p:cBhvr>
+                                    </p:animRot>
+                                    <p:animRot by="-240000">
+                                      <p:cBhvr>
+                                        <p:cTn id="13" dur="200" fill="hold">
+                                          <p:stCondLst>
+                                            <p:cond delay="200"/>
+                                          </p:stCondLst>
+                                        </p:cTn>
+                                        <p:tgtEl>
+                                          <p:spTgt spid="2"/>
+                                        </p:tgtEl>
+                                        <p:attrNameLst>
+                                          <p:attrName>r</p:attrName>
+                                        </p:attrNameLst>
+                                      </p:cBhvr>
+                                    </p:animRot>
+                                    <p:animRot by="240000">
+                                      <p:cBhvr>
+                                        <p:cTn id="14" dur="200" fill="hold">
+                                          <p:stCondLst>
+                                            <p:cond delay="400"/>
+                                          </p:stCondLst>
+                                        </p:cTn>
+                                        <p:tgtEl>
+                                          <p:spTgt spid="2"/>
+                                        </p:tgtEl>
+                                        <p:attrNameLst>
+                                          <p:attrName>r</p:attrName>
+                                        </p:attrNameLst>
+                                      </p:cBhvr>
+                                    </p:animRot>
+                                    <p:animRot by="-240000">
+                                      <p:cBhvr>
+                                        <p:cTn id="15" dur="200" fill="hold">
+                                          <p:stCondLst>
+                                            <p:cond delay="600"/>
+                                          </p:stCondLst>
+                                        </p:cTn>
+                                        <p:tgtEl>
+                                          <p:spTgt spid="2"/>
+                                        </p:tgtEl>
+                                        <p:attrNameLst>
+                                          <p:attrName>r</p:attrName>
+                                        </p:attrNameLst>
+                                      </p:cBhvr>
+                                    </p:animRot>
+                                    <p:animRot by="120000">
+                                      <p:cBhvr>
+                                        <p:cTn id="16" dur="200" fill="hold">
+                                          <p:stCondLst>
+                                            <p:cond delay="800"/>
+                                          </p:stCondLst>
+                                        </p:cTn>
+                                        <p:tgtEl>
+                                          <p:spTgt spid="2"/>
+                                        </p:tgtEl>
+                                        <p:attrNameLst>
+                                          <p:attrName>r</p:attrName>
+                                        </p:attrNameLst>
+                                      </p:cBhvr>
+                                    </p:animRot>
+                                  </p:childTnLst>
+                                </p:cTn>
+                              </p:par>
+                            </p:childTnLst>
+                          </p:cTn>
+                        </p:par>
+                      </p:childTnLst>
+                    </p:cTn>
+                  </p:par>
+                </p:childTnLst>
+              </p:cTn>
+              <p:prevCondLst>
+                <p:cond evt="onPrev" delay="0">
+                  <p:tgtEl>
+                    <p:sldTgt/>
+                  </p:tgtEl>
+                </p:cond>
+              </p:prevCondLst>
+              <p:nextCondLst>
+                <p:cond evt="onNext" delay="0">
+                  <p:tgtEl>
+                    <p:sldTgt/>
+                  </p:tgtEl>
+                </p:cond>
+              </p:nextCondLst>
+            </p:seq>
+          </p:childTnLst>
+        </p:cTn>
+      </p:par>
+    </p:tnLst>
+  </p:timing>
+</p:sld>
+</file>
+
 <file path=ppt/theme/theme1.xml><?xml version="1.0" encoding="utf-8"?>
 <a:theme xmlns:a="http://schemas.openxmlformats.org/drawingml/2006/main" name="College Lessons with Cycle Diagrams by Slidesgo">
   <a:themeElements>

</xml_diff>